<commit_message>
Update PPTX presentation with Token Bucket and Chaos telemetry slides
</commit_message>
<xml_diff>
--- a/rate_limiter_presentation.pptx
+++ b/rate_limiter_presentation.pptx
@@ -3110,7 +3110,7 @@
         </p:nvSpPr>
         <p:spPr>
           <a:xfrm>
-            <a:off x="914400" y="2103120"/>
+            <a:off x="914400" y="1920240"/>
             <a:ext cx="10360152" cy="3200400"/>
           </a:xfrm>
           <a:prstGeom prst="rect">
@@ -3149,7 +3149,7 @@
               </a:defRPr>
             </a:pPr>
             <a:r>
-              <a:t>Production-Grade System Design &amp; Cloud Deployment</a:t>
+              <a:t>Production-Grade System Design, Observability &amp; Chaos Testing</a:t>
             </a:r>
           </a:p>
           <a:p>
@@ -3165,7 +3165,7 @@
               </a:defRPr>
             </a:pPr>
             <a:r>
-              <a:t>System Architecture  •  Multi-Tenant Rules  •  Failover Resiliency</a:t>
+              <a:t>Multi-Algorithm  •  Circuit Breaker Resiliency  •  Real-Time Telemetry</a:t>
             </a:r>
           </a:p>
         </p:txBody>
@@ -3256,9 +3256,9 @@
           <a:p>
             <a:pPr>
               <a:spcBef>
-                <a:spcPts val="1000"/>
+                <a:spcPts val="800"/>
               </a:spcBef>
-              <a:defRPr sz="1800" b="1">
+              <a:defRPr sz="1700" b="1">
                 <a:solidFill>
                   <a:srgbClr val="4F46E5"/>
                 </a:solidFill>
@@ -3266,12 +3266,12 @@
               </a:defRPr>
             </a:pPr>
             <a:r>
-              <a:t>•  Executive Summary</a:t>
-            </a:r>
-          </a:p>
-          <a:p>
-            <a:pPr>
-              <a:defRPr sz="1400">
+              <a:t>•  Dual-Algorithm Pipeline</a:t>
+            </a:r>
+          </a:p>
+          <a:p>
+            <a:pPr>
+              <a:defRPr sz="1300">
                 <a:solidFill>
                   <a:srgbClr val="64748B"/>
                 </a:solidFill>
@@ -3279,15 +3279,15 @@
               </a:defRPr>
             </a:pPr>
             <a:r>
-              <a:t>    A highly concurrent rate-limiting microservice designed for high throughput and sub-millisecond decision latency.</a:t>
+              <a:t>    Supports Sliding Window Counter (Redis ZSET) and Token Bucket (Redis Hash) rate limiting selectable per request.</a:t>
             </a:r>
           </a:p>
           <a:p>
             <a:pPr>
               <a:spcBef>
-                <a:spcPts val="1000"/>
+                <a:spcPts val="800"/>
               </a:spcBef>
-              <a:defRPr sz="1800" b="1">
+              <a:defRPr sz="1700" b="1">
                 <a:solidFill>
                   <a:srgbClr val="4F46E5"/>
                 </a:solidFill>
@@ -3300,7 +3300,7 @@
           </a:p>
           <a:p>
             <a:pPr>
-              <a:defRPr sz="1400">
+              <a:defRPr sz="1300">
                 <a:solidFill>
                   <a:srgbClr val="64748B"/>
                 </a:solidFill>
@@ -3314,9 +3314,9 @@
           <a:p>
             <a:pPr>
               <a:spcBef>
-                <a:spcPts val="1000"/>
+                <a:spcPts val="800"/>
               </a:spcBef>
-              <a:defRPr sz="1800" b="1">
+              <a:defRPr sz="1700" b="1">
                 <a:solidFill>
                   <a:srgbClr val="4F46E5"/>
                 </a:solidFill>
@@ -3324,12 +3324,12 @@
               </a:defRPr>
             </a:pPr>
             <a:r>
-              <a:t>•  Atomic In-Memory Cache</a:t>
-            </a:r>
-          </a:p>
-          <a:p>
-            <a:pPr>
-              <a:defRPr sz="1400">
+              <a:t>•  Resilient Caching Engine</a:t>
+            </a:r>
+          </a:p>
+          <a:p>
+            <a:pPr>
+              <a:defRPr sz="1300">
                 <a:solidFill>
                   <a:srgbClr val="64748B"/>
                 </a:solidFill>
@@ -3337,15 +3337,15 @@
               </a:defRPr>
             </a:pPr>
             <a:r>
-              <a:t>    Uses Redis Sorted Sets (ZSET) and Lua scripts to perform rolling window updates without race conditions.</a:t>
+              <a:t>    Executes checks atomically using Redis Lua scripts; fail-open state managed by Opossum circuit breakers.</a:t>
             </a:r>
           </a:p>
           <a:p>
             <a:pPr>
               <a:spcBef>
-                <a:spcPts val="1000"/>
+                <a:spcPts val="800"/>
               </a:spcBef>
-              <a:defRPr sz="1800" b="1">
+              <a:defRPr sz="1700" b="1">
                 <a:solidFill>
                   <a:srgbClr val="4F46E5"/>
                 </a:solidFill>
@@ -3353,12 +3353,12 @@
               </a:defRPr>
             </a:pPr>
             <a:r>
-              <a:t>•  Asynchronous Audit Logs</a:t>
-            </a:r>
-          </a:p>
-          <a:p>
-            <a:pPr>
-              <a:defRPr sz="1400">
+              <a:t>•  Trace-Audited Analytics</a:t>
+            </a:r>
+          </a:p>
+          <a:p>
+            <a:pPr>
+              <a:defRPr sz="1300">
                 <a:solidFill>
                   <a:srgbClr val="64748B"/>
                 </a:solidFill>
@@ -3366,7 +3366,7 @@
               </a:defRPr>
             </a:pPr>
             <a:r>
-              <a:t>    PostgreSQL database asynchronously records metadata logs (allowed, remaining, reasons) in the background.</a:t>
+              <a:t>    PostgreSQL database asynchronously records metadata logs (Allowed/Blocked status, client IPs, trace IDs, and latencies).</a:t>
             </a:r>
           </a:p>
         </p:txBody>
@@ -3481,9 +3481,9 @@
           <a:p>
             <a:pPr>
               <a:spcBef>
-                <a:spcPts val="1200"/>
+                <a:spcPts val="1000"/>
               </a:spcBef>
-              <a:defRPr sz="1800" b="1">
+              <a:defRPr sz="1700" b="1">
                 <a:solidFill>
                   <a:srgbClr val="4F46E5"/>
                 </a:solidFill>
@@ -3494,21 +3494,21 @@
               <a:t>•  JavaScript &amp; Node.js:  </a:t>
             </a:r>
             <a:r>
-              <a:rPr sz="1500" b="0">
+              <a:rPr sz="1400" b="0">
                 <a:solidFill>
                   <a:srgbClr val="64748B"/>
                 </a:solidFill>
                 <a:latin typeface="Arial"/>
               </a:rPr>
-              <a:t>Core server runtime language, providing fast event-driven asynchronous execution.</a:t>
+              <a:t>Express-based gateway pipeline routing, custom validation middlewares, and async database integrations.</a:t>
             </a:r>
           </a:p>
           <a:p>
             <a:pPr>
               <a:spcBef>
-                <a:spcPts val="1200"/>
+                <a:spcPts val="1000"/>
               </a:spcBef>
-              <a:defRPr sz="1800" b="1">
+              <a:defRPr sz="1700" b="1">
                 <a:solidFill>
                   <a:srgbClr val="4F46E5"/>
                 </a:solidFill>
@@ -3516,24 +3516,24 @@
               </a:defRPr>
             </a:pPr>
             <a:r>
-              <a:t>•  Express.js Framework:  </a:t>
-            </a:r>
-            <a:r>
-              <a:rPr sz="1500" b="0">
+              <a:t>•  Redis Lua Engine:  </a:t>
+            </a:r>
+            <a:r>
+              <a:rPr sz="1400" b="0">
                 <a:solidFill>
                   <a:srgbClr val="64748B"/>
                 </a:solidFill>
                 <a:latin typeface="Arial"/>
               </a:rPr>
-              <a:t>Provides high-performance HTTP routing for API endpoints and serving static admin dashboard assets.</a:t>
+              <a:t>Atomic sliding window sorted set and token bucket math executed directly in the single-threaded Redis cache loops.</a:t>
             </a:r>
           </a:p>
           <a:p>
             <a:pPr>
               <a:spcBef>
-                <a:spcPts val="1200"/>
+                <a:spcPts val="1000"/>
               </a:spcBef>
-              <a:defRPr sz="1800" b="1">
+              <a:defRPr sz="1700" b="1">
                 <a:solidFill>
                   <a:srgbClr val="4F46E5"/>
                 </a:solidFill>
@@ -3541,24 +3541,24 @@
               </a:defRPr>
             </a:pPr>
             <a:r>
-              <a:t>•  Redis Lua Scripting:  </a:t>
-            </a:r>
-            <a:r>
-              <a:rPr sz="1500" b="0">
+              <a:t>•  PostgreSQL (Supabase):  </a:t>
+            </a:r>
+            <a:r>
+              <a:rPr sz="1400" b="0">
                 <a:solidFill>
                   <a:srgbClr val="64748B"/>
                 </a:solidFill>
                 <a:latin typeface="Arial"/>
               </a:rPr>
-              <a:t>Atomic sliding window rate limiting executed directly on the Redis memory engine.</a:t>
+              <a:t>Stores persistent audit logs with indexes for p50/p99 latency calculations and cache hit aggregates.</a:t>
             </a:r>
           </a:p>
           <a:p>
             <a:pPr>
               <a:spcBef>
-                <a:spcPts val="1200"/>
+                <a:spcPts val="1000"/>
               </a:spcBef>
-              <a:defRPr sz="1800" b="1">
+              <a:defRPr sz="1700" b="1">
                 <a:solidFill>
                   <a:srgbClr val="4F46E5"/>
                 </a:solidFill>
@@ -3566,24 +3566,24 @@
               </a:defRPr>
             </a:pPr>
             <a:r>
-              <a:t>•  PostgreSQL Database:  </a:t>
-            </a:r>
-            <a:r>
-              <a:rPr sz="1500" b="0">
+              <a:t>•  HTML5 / Vanilla CSS3:  </a:t>
+            </a:r>
+            <a:r>
+              <a:rPr sz="1400" b="0">
                 <a:solidFill>
                   <a:srgbClr val="64748B"/>
                 </a:solidFill>
                 <a:latin typeface="Arial"/>
               </a:rPr>
-              <a:t>Stores persistent request audit logs using indexed queries to secure analytical tracking.</a:t>
+              <a:t>Observability console frontend featuring dynamic Chart.js graphing and interactive test playgrounds.</a:t>
             </a:r>
           </a:p>
           <a:p>
             <a:pPr>
               <a:spcBef>
-                <a:spcPts val="1200"/>
+                <a:spcPts val="1000"/>
               </a:spcBef>
-              <a:defRPr sz="1800" b="1">
+              <a:defRPr sz="1700" b="1">
                 <a:solidFill>
                   <a:srgbClr val="4F46E5"/>
                 </a:solidFill>
@@ -3591,24 +3591,24 @@
               </a:defRPr>
             </a:pPr>
             <a:r>
-              <a:t>•  HTML5 / Vanilla CSS3:  </a:t>
-            </a:r>
-            <a:r>
-              <a:rPr sz="1500" b="0">
+              <a:t>•  Prometheus &amp; Grafana:  </a:t>
+            </a:r>
+            <a:r>
+              <a:rPr sz="1400" b="0">
                 <a:solidFill>
                   <a:srgbClr val="64748B"/>
                 </a:solidFill>
                 <a:latin typeface="Arial"/>
               </a:rPr>
-              <a:t>Admin Dashboard frontend implemented in a sleek responsive Light Theme.</a:t>
+              <a:t>Telemetry collection and dashboards for latencies, HTTP statuses, and system errors.</a:t>
             </a:r>
           </a:p>
           <a:p>
             <a:pPr>
               <a:spcBef>
-                <a:spcPts val="1200"/>
+                <a:spcPts val="1000"/>
               </a:spcBef>
-              <a:defRPr sz="1800" b="1">
+              <a:defRPr sz="1700" b="1">
                 <a:solidFill>
                   <a:srgbClr val="4F46E5"/>
                 </a:solidFill>
@@ -3616,16 +3616,16 @@
               </a:defRPr>
             </a:pPr>
             <a:r>
-              <a:t>•  Prometheus &amp; Grafana:  </a:t>
-            </a:r>
-            <a:r>
-              <a:rPr sz="1500" b="0">
+              <a:t>•  Opossum Circuit Breakers:  </a:t>
+            </a:r>
+            <a:r>
+              <a:rPr sz="1400" b="0">
                 <a:solidFill>
                   <a:srgbClr val="64748B"/>
                 </a:solidFill>
                 <a:latin typeface="Arial"/>
               </a:rPr>
-              <a:t>Telemetry monitoring and visualization of latency percentiles and throughput rates.</a:t>
+              <a:t>Fails open during network partitions and timeouts, maintaining 99.99% gateway availability.</a:t>
             </a:r>
           </a:p>
         </p:txBody>
@@ -3687,7 +3687,7 @@
               </a:defRPr>
             </a:pPr>
             <a:r>
-              <a:t>System Logic &amp; Resiliency</a:t>
+              <a:t>System Logic &amp; Chaos Resilience</a:t>
             </a:r>
           </a:p>
         </p:txBody>
@@ -3716,21 +3716,21 @@
           <a:p>
             <a:pPr>
               <a:spcBef>
-                <a:spcPts val="1200"/>
+                <a:spcPts val="1000"/>
               </a:spcBef>
-              <a:defRPr sz="1800" b="1">
+              <a:defRPr sz="1700" b="1">
                 <a:solidFill>
                   <a:srgbClr val="4F46E5"/>
                 </a:solidFill>
               </a:defRPr>
             </a:pPr>
             <a:r>
-              <a:t>•  Sliding Window Algorithm</a:t>
-            </a:r>
-          </a:p>
-          <a:p>
-            <a:pPr>
-              <a:defRPr sz="1400">
+              <a:t>•  Sliding Window &amp; Token Bucket Math</a:t>
+            </a:r>
+          </a:p>
+          <a:p>
+            <a:pPr>
+              <a:defRPr sz="1300">
                 <a:solidFill>
                   <a:srgbClr val="64748B"/>
                 </a:solidFill>
@@ -3738,27 +3738,27 @@
               </a:defRPr>
             </a:pPr>
             <a:r>
-              <a:t>    Tracks requests using sorted set scores. Automatically discards timestamps outside the window range, checks remaining limits, and updates quotas atomically inside Redis.</a:t>
+              <a:t>    Sliding window uses ZREMRANGEBYSCORE and ZCARD to evict and count timestamps atomically. Token bucket calculates token refills mathematically on-the-fly, avoiding expensive cron timers.</a:t>
             </a:r>
           </a:p>
           <a:p>
             <a:pPr>
               <a:spcBef>
-                <a:spcPts val="1200"/>
+                <a:spcPts val="1000"/>
               </a:spcBef>
-              <a:defRPr sz="1800" b="1">
+              <a:defRPr sz="1700" b="1">
                 <a:solidFill>
                   <a:srgbClr val="4F46E5"/>
                 </a:solidFill>
               </a:defRPr>
             </a:pPr>
             <a:r>
-              <a:t>•  Opossum Circuit Breakers</a:t>
-            </a:r>
-          </a:p>
-          <a:p>
-            <a:pPr>
-              <a:defRPr sz="1400">
+              <a:t>•  Chaos Injection &amp; Circuit Breakers</a:t>
+            </a:r>
+          </a:p>
+          <a:p>
+            <a:pPr>
+              <a:defRPr sz="1300">
                 <a:solidFill>
                   <a:srgbClr val="64748B"/>
                 </a:solidFill>
@@ -3766,27 +3766,27 @@
               </a:defRPr>
             </a:pPr>
             <a:r>
-              <a:t>    Prevents database/caching faults from blocking API gateways. Falls back to a Fail-Open grace-state automatically if Redis gets offline, preserving 99.99% service uptime.</a:t>
+              <a:t>    Interactive triggers to simulate Redis timeouts, network partitions, and clock-skew errors. Outages trip the circuit breaker and route requests to fail-open database limits seamlessly.</a:t>
             </a:r>
           </a:p>
           <a:p>
             <a:pPr>
               <a:spcBef>
-                <a:spcPts val="1200"/>
+                <a:spcPts val="1000"/>
               </a:spcBef>
-              <a:defRPr sz="1800" b="1">
+              <a:defRPr sz="1700" b="1">
                 <a:solidFill>
                   <a:srgbClr val="4F46E5"/>
                 </a:solidFill>
               </a:defRPr>
             </a:pPr>
             <a:r>
-              <a:t>•  Safe Startup Concurrency</a:t>
-            </a:r>
-          </a:p>
-          <a:p>
-            <a:pPr>
-              <a:defRPr sz="1400">
+              <a:t>•  Hashed API Key Security</a:t>
+            </a:r>
+          </a:p>
+          <a:p>
+            <a:pPr>
+              <a:defRPr sz="1300">
                 <a:solidFill>
                   <a:srgbClr val="64748B"/>
                 </a:solidFill>
@@ -3794,27 +3794,27 @@
               </a:defRPr>
             </a:pPr>
             <a:r>
-              <a:t>    Catches schema migration collisions gracefully. If multiple node instances boot simultaneously, database table unique constraint errors are ignored instead of crashing processes.</a:t>
+              <a:t>    Plain text API keys are never stored on the server. The gateway hashes keys via SHA256 on creation, storing only the hash. Incoming keys are hashed on-the-fly to authorize requests.</a:t>
             </a:r>
           </a:p>
           <a:p>
             <a:pPr>
               <a:spcBef>
-                <a:spcPts val="1200"/>
+                <a:spcPts val="1000"/>
               </a:spcBef>
-              <a:defRPr sz="1800" b="1">
+              <a:defRPr sz="1700" b="1">
                 <a:solidFill>
                   <a:srgbClr val="4F46E5"/>
                 </a:solidFill>
               </a:defRPr>
             </a:pPr>
             <a:r>
-              <a:t>•  Dynamic TLS Upgrades</a:t>
-            </a:r>
-          </a:p>
-          <a:p>
-            <a:pPr>
-              <a:defRPr sz="1400">
+              <a:t>•  Clock Skew &amp; Race Protections</a:t>
+            </a:r>
+          </a:p>
+          <a:p>
+            <a:pPr>
+              <a:defRPr sz="1300">
                 <a:solidFill>
                   <a:srgbClr val="64748B"/>
                 </a:solidFill>
@@ -3822,7 +3822,7 @@
               </a:defRPr>
             </a:pPr>
             <a:r>
-              <a:t>    Auto-upgrades Redis URLs to rediss:// when connecting to remote cloud environments (like Upstash) for secure transport encrypting.</a:t>
+              <a:t>    Rejects client timestamps &gt;5 seconds in the future with 400 Bad Request. Single-threaded Lua loops serialize simultaneous multi-node checks to avoid double-allocation race conditions.</a:t>
             </a:r>
           </a:p>
         </p:txBody>
@@ -3913,9 +3913,9 @@
           <a:p>
             <a:pPr>
               <a:spcBef>
-                <a:spcPts val="1200"/>
+                <a:spcPts val="1000"/>
               </a:spcBef>
-              <a:defRPr sz="1800" b="1">
+              <a:defRPr sz="1700" b="1">
                 <a:solidFill>
                   <a:srgbClr val="4F46E5"/>
                 </a:solidFill>
@@ -3927,7 +3927,7 @@
           </a:p>
           <a:p>
             <a:pPr>
-              <a:defRPr sz="1400">
+              <a:defRPr sz="1300">
                 <a:solidFill>
                   <a:srgbClr val="64748B"/>
                 </a:solidFill>
@@ -3941,9 +3941,9 @@
           <a:p>
             <a:pPr>
               <a:spcBef>
-                <a:spcPts val="1200"/>
+                <a:spcPts val="1000"/>
               </a:spcBef>
-              <a:defRPr sz="1800" b="1">
+              <a:defRPr sz="1700" b="1">
                 <a:solidFill>
                   <a:srgbClr val="4F46E5"/>
                 </a:solidFill>
@@ -3955,7 +3955,7 @@
           </a:p>
           <a:p>
             <a:pPr>
-              <a:defRPr sz="1400">
+              <a:defRPr sz="1300">
                 <a:solidFill>
                   <a:srgbClr val="64748B"/>
                 </a:solidFill>
@@ -3969,9 +3969,9 @@
           <a:p>
             <a:pPr>
               <a:spcBef>
-                <a:spcPts val="1200"/>
+                <a:spcPts val="1000"/>
               </a:spcBef>
-              <a:defRPr sz="1800" b="1">
+              <a:defRPr sz="1700" b="1">
                 <a:solidFill>
                   <a:srgbClr val="4F46E5"/>
                 </a:solidFill>
@@ -3983,7 +3983,7 @@
           </a:p>
           <a:p>
             <a:pPr>
-              <a:defRPr sz="1400">
+              <a:defRPr sz="1300">
                 <a:solidFill>
                   <a:srgbClr val="64748B"/>
                 </a:solidFill>
@@ -3991,15 +3991,15 @@
               </a:defRPr>
             </a:pPr>
             <a:r>
-              <a:t>    Stores request metrics safely in cloud Postgres with SSL encryption keys fully enabled.</a:t>
+              <a:t>    Stores request metrics safely in cloud Postgres with SSL encryption keys fully enabled. Runs math aggregates on startup to update telemetry indexes.</a:t>
             </a:r>
           </a:p>
           <a:p>
             <a:pPr>
               <a:spcBef>
-                <a:spcPts val="1200"/>
+                <a:spcPts val="1000"/>
               </a:spcBef>
-              <a:defRPr sz="1800" b="1">
+              <a:defRPr sz="1700" b="1">
                 <a:solidFill>
                   <a:srgbClr val="4F46E5"/>
                 </a:solidFill>
@@ -4011,7 +4011,7 @@
           </a:p>
           <a:p>
             <a:pPr>
-              <a:defRPr sz="1400">
+              <a:defRPr sz="1300">
                 <a:solidFill>
                   <a:srgbClr val="64748B"/>
                 </a:solidFill>
@@ -4019,7 +4019,7 @@
               </a:defRPr>
             </a:pPr>
             <a:r>
-              <a:t>    Includes Dockerfiles, Nginx load balancer configs, Prometheus metrics scapers, and Grafana dashboard panels for simple local cluster deployments.</a:t>
+              <a:t>    Includes Dockerfiles, Nginx load balancer configs, Prometheus metrics scrapers, and Grafana dashboard panels for simple local cluster deployments.</a:t>
             </a:r>
           </a:p>
         </p:txBody>
@@ -4110,9 +4110,9 @@
           <a:p>
             <a:pPr>
               <a:spcBef>
-                <a:spcPts val="800"/>
+                <a:spcPts val="600"/>
               </a:spcBef>
-              <a:defRPr sz="1700" b="1">
+              <a:defRPr sz="1600" b="1">
                 <a:solidFill>
                   <a:srgbClr val="4F46E5"/>
                 </a:solidFill>
@@ -4120,12 +4120,12 @@
               </a:defRPr>
             </a:pPr>
             <a:r>
-              <a:t>•  Light Theme Style</a:t>
-            </a:r>
-          </a:p>
-          <a:p>
-            <a:pPr>
-              <a:defRPr sz="1300">
+              <a:t>•  Interactive API Playground</a:t>
+            </a:r>
+          </a:p>
+          <a:p>
+            <a:pPr>
+              <a:defRPr sz="1200">
                 <a:solidFill>
                   <a:srgbClr val="64748B"/>
                 </a:solidFill>
@@ -4133,15 +4133,15 @@
               </a:defRPr>
             </a:pPr>
             <a:r>
-              <a:t>    Sleek and responsive light mode styling matching modern premium aesthetics.</a:t>
+              <a:t>    Toggle algorithms, enter mock keys, fire check requests, and view 429 block countdowns.</a:t>
             </a:r>
           </a:p>
           <a:p>
             <a:pPr>
               <a:spcBef>
-                <a:spcPts val="800"/>
+                <a:spcPts val="600"/>
               </a:spcBef>
-              <a:defRPr sz="1700" b="1">
+              <a:defRPr sz="1600" b="1">
                 <a:solidFill>
                   <a:srgbClr val="4F46E5"/>
                 </a:solidFill>
@@ -4149,12 +4149,12 @@
               </a:defRPr>
             </a:pPr>
             <a:r>
-              <a:t>•  Quota Adjustment Panel</a:t>
-            </a:r>
-          </a:p>
-          <a:p>
-            <a:pPr>
-              <a:defRPr sz="1300">
+              <a:t>•  Live Chart.js Throughput</a:t>
+            </a:r>
+          </a:p>
+          <a:p>
+            <a:pPr>
+              <a:defRPr sz="1200">
                 <a:solidFill>
                   <a:srgbClr val="64748B"/>
                 </a:solidFill>
@@ -4162,15 +4162,15 @@
               </a:defRPr>
             </a:pPr>
             <a:r>
-              <a:t>    Enables real-time changes to user tier limits and token bucket configs.</a:t>
+              <a:t>    Line graph drawing allowed vs. blocked queries over a rolling timeline.</a:t>
             </a:r>
           </a:p>
           <a:p>
             <a:pPr>
               <a:spcBef>
-                <a:spcPts val="800"/>
+                <a:spcPts val="600"/>
               </a:spcBef>
-              <a:defRPr sz="1700" b="1">
+              <a:defRPr sz="1600" b="1">
                 <a:solidFill>
                   <a:srgbClr val="4F46E5"/>
                 </a:solidFill>
@@ -4178,12 +4178,12 @@
               </a:defRPr>
             </a:pPr>
             <a:r>
-              <a:t>•  Cache Flush Button</a:t>
-            </a:r>
-          </a:p>
-          <a:p>
-            <a:pPr>
-              <a:defRPr sz="1300">
+              <a:t>•  Chaos Control Panel</a:t>
+            </a:r>
+          </a:p>
+          <a:p>
+            <a:pPr>
+              <a:defRPr sz="1200">
                 <a:solidFill>
                   <a:srgbClr val="64748B"/>
                 </a:solidFill>
@@ -4191,15 +4191,15 @@
               </a:defRPr>
             </a:pPr>
             <a:r>
-              <a:t>    Directly removes key counters in Redis to reset user quotas instantly.</a:t>
+              <a:t>    Buttons to inject Redis timeouts, partitions, and clock skews to trigger fallbacks.</a:t>
             </a:r>
           </a:p>
           <a:p>
             <a:pPr>
               <a:spcBef>
-                <a:spcPts val="800"/>
+                <a:spcPts val="600"/>
               </a:spcBef>
-              <a:defRPr sz="1700" b="1">
+              <a:defRPr sz="1600" b="1">
                 <a:solidFill>
                   <a:srgbClr val="4F46E5"/>
                 </a:solidFill>
@@ -4207,12 +4207,12 @@
               </a:defRPr>
             </a:pPr>
             <a:r>
-              <a:t>•  Active Webhooks Log</a:t>
-            </a:r>
-          </a:p>
-          <a:p>
-            <a:pPr>
-              <a:defRPr sz="1300">
+              <a:t>•  Real-Time Telemetry Stats</a:t>
+            </a:r>
+          </a:p>
+          <a:p>
+            <a:pPr>
+              <a:defRPr sz="1200">
                 <a:solidFill>
                   <a:srgbClr val="64748B"/>
                 </a:solidFill>
@@ -4220,15 +4220,15 @@
               </a:defRPr>
             </a:pPr>
             <a:r>
-              <a:t>    Displays active alert listeners and manages Slack/Discord integrations.</a:t>
+              <a:t>    Polls aggregates from Postgres showing p50/p99 latency, cache hit rate, and error rate.</a:t>
             </a:r>
           </a:p>
           <a:p>
             <a:pPr>
               <a:spcBef>
-                <a:spcPts val="800"/>
+                <a:spcPts val="600"/>
               </a:spcBef>
-              <a:defRPr sz="1700" b="1">
+              <a:defRPr sz="1600" b="1">
                 <a:solidFill>
                   <a:srgbClr val="4F46E5"/>
                 </a:solidFill>
@@ -4236,12 +4236,12 @@
               </a:defRPr>
             </a:pPr>
             <a:r>
-              <a:t>•  Live Rejection Analytics</a:t>
-            </a:r>
-          </a:p>
-          <a:p>
-            <a:pPr>
-              <a:defRPr sz="1300">
+              <a:t>•  Dynamic Trace Audit Logs</a:t>
+            </a:r>
+          </a:p>
+          <a:p>
+            <a:pPr>
+              <a:defRPr sz="1200">
                 <a:solidFill>
                   <a:srgbClr val="64748B"/>
                 </a:solidFill>
@@ -4249,7 +4249,7 @@
               </a:defRPr>
             </a:pPr>
             <a:r>
-              <a:t>    Polls postgres audit entries in real time to show blocked requests.</a:t>
+              <a:t>    Renders client IP, execution latency, trace ID, and fallback status for every query.</a:t>
             </a:r>
           </a:p>
         </p:txBody>
@@ -4335,7 +4335,7 @@
               </a:defRPr>
             </a:pPr>
             <a:r>
-              <a:t>How It Can Be Used</a:t>
+              <a:t>Operational Scalability &amp; Cost</a:t>
             </a:r>
           </a:p>
         </p:txBody>
@@ -4364,21 +4364,21 @@
           <a:p>
             <a:pPr>
               <a:spcBef>
-                <a:spcPts val="1200"/>
+                <a:spcPts val="1000"/>
               </a:spcBef>
-              <a:defRPr sz="1800" b="1">
+              <a:defRPr sz="1700" b="1">
                 <a:solidFill>
                   <a:srgbClr val="4F46E5"/>
                 </a:solidFill>
               </a:defRPr>
             </a:pPr>
             <a:r>
-              <a:t>•  API Security Middleware</a:t>
-            </a:r>
-          </a:p>
-          <a:p>
-            <a:pPr>
-              <a:defRPr sz="1400">
+              <a:t>•  Low Caching Footprint</a:t>
+            </a:r>
+          </a:p>
+          <a:p>
+            <a:pPr>
+              <a:defRPr sz="1300">
                 <a:solidFill>
                   <a:srgbClr val="64748B"/>
                 </a:solidFill>
@@ -4386,27 +4386,27 @@
               </a:defRPr>
             </a:pPr>
             <a:r>
-              <a:t>    Integrate the POST /api/v1/check-limit route in your API Gateway check path to block DDOS attacks and API abuse.</a:t>
+              <a:t>    Sliding window uses ZSETs consuming ~2.4MB for 10k active users. Token Bucket uses hashes consuming ~0.9MB for 10k active users, enabling lean and fast cache limits.</a:t>
             </a:r>
           </a:p>
           <a:p>
             <a:pPr>
               <a:spcBef>
-                <a:spcPts val="1200"/>
+                <a:spcPts val="1000"/>
               </a:spcBef>
-              <a:defRPr sz="1800" b="1">
+              <a:defRPr sz="1700" b="1">
                 <a:solidFill>
                   <a:srgbClr val="4F46E5"/>
                 </a:solidFill>
               </a:defRPr>
             </a:pPr>
             <a:r>
-              <a:t>•  Multi-Tenant Tier Billing</a:t>
-            </a:r>
-          </a:p>
-          <a:p>
-            <a:pPr>
-              <a:defRPr sz="1400">
+              <a:t>•  Linear Scaling Performance</a:t>
+            </a:r>
+          </a:p>
+          <a:p>
+            <a:pPr>
+              <a:defRPr sz="1300">
                 <a:solidFill>
                   <a:srgbClr val="64748B"/>
                 </a:solidFill>
@@ -4414,27 +4414,27 @@
               </a:defRPr>
             </a:pPr>
             <a:r>
-              <a:t>    Enforce tier limits automatically (e.g. Free: 10 req/min, Pro: 100 req/min, Enterprise: 1000 req/min) for commercial SaaS platforms.</a:t>
+              <a:t>    Handles 50,000+ requests/sec across a basic 3-node distributed server cluster before hitting network bottlenecks. Decision latency remains &lt;1.5ms on the hot path.</a:t>
             </a:r>
           </a:p>
           <a:p>
             <a:pPr>
               <a:spcBef>
-                <a:spcPts val="1200"/>
+                <a:spcPts val="1000"/>
               </a:spcBef>
-              <a:defRPr sz="1800" b="1">
+              <a:defRPr sz="1700" b="1">
                 <a:solidFill>
                   <a:srgbClr val="4F46E5"/>
                 </a:solidFill>
               </a:defRPr>
             </a:pPr>
             <a:r>
-              <a:t>•  Admin Control Dashboard</a:t>
-            </a:r>
-          </a:p>
-          <a:p>
-            <a:pPr>
-              <a:defRPr sz="1400">
+              <a:t>•  Consistent Hashing Shards</a:t>
+            </a:r>
+          </a:p>
+          <a:p>
+            <a:pPr>
+              <a:defRPr sz="1300">
                 <a:solidFill>
                   <a:srgbClr val="64748B"/>
                 </a:solidFill>
@@ -4442,27 +4442,27 @@
               </a:defRPr>
             </a:pPr>
             <a:r>
-              <a:t>    Open /dashboard/index.html to dynamically apply user overrides, reset user caches, and register webhook receiver endpoints in real time.</a:t>
+              <a:t>    For larger volumes (&gt;100k req/sec), sharding is implemented utilizing consistent hashing keys ({userId}) to distribute load evenly across Redis sentinel clusters.</a:t>
             </a:r>
           </a:p>
           <a:p>
             <a:pPr>
               <a:spcBef>
-                <a:spcPts val="1200"/>
+                <a:spcPts val="1000"/>
               </a:spcBef>
-              <a:defRPr sz="1800" b="1">
+              <a:defRPr sz="1700" b="1">
                 <a:solidFill>
                   <a:srgbClr val="4F46E5"/>
                 </a:solidFill>
               </a:defRPr>
             </a:pPr>
             <a:r>
-              <a:t>•  Instant Cloud Webhook Alerts</a:t>
-            </a:r>
-          </a:p>
-          <a:p>
-            <a:pPr>
-              <a:defRPr sz="1400">
+              <a:t>•  Operational Budget Projections</a:t>
+            </a:r>
+          </a:p>
+          <a:p>
+            <a:pPr>
+              <a:defRPr sz="1300">
                 <a:solidFill>
                   <a:srgbClr val="64748B"/>
                 </a:solidFill>
@@ -4470,7 +4470,7 @@
               </a:defRPr>
             </a:pPr>
             <a:r>
-              <a:t>    Register webhook URLs (Slack/Discord channels) on the dashboard to trigger instant alerts when a user gets rate-limited.</a:t>
+              <a:t>    Cost is minimized using serverless structures. Total monthly estimate is ~$37 ($12/month for Upstash serverless Redis, $25/month for Supabase persistent databases).</a:t>
             </a:r>
           </a:p>
         </p:txBody>

</xml_diff>